<commit_message>
Fix nine line citations my previous pass missed
A title that cites two ranges writes the second one without the "Lines" prefix
-- "(Lines 535 to 572, 589 to 592)" -- and the last commit matched on the
prefix, so every second citation in the four proposal decks stayed at its
pre-shift value. The live deck has no combined titles and was already correct.

Re-checked by validating every "N to M" in all five decks against the set of
ranges actually present in tutorial_HIL_driver.py, rather than by searching for
the strings I expected to find. That is the check that would have caught it the
first time, and it now reports zero.

Co-Authored-By: Claude Opus 5 (1M context) <noreply@anthropic.com>
Claude-Session: https://claude.ai/code/session_014fv6Q7ayo2WG4sN2VbeX4J
</commit_message>
<xml_diff>
--- a/proposals/A_why_first.pptx
+++ b/proposals/A_why_first.pptx
@@ -6554,7 +6554,7 @@
           <a:p>
             <a:r>
               <a:rPr sz="2600"/>
-              <a:t>The keyboard, and the free gear keys (Lines 535 to 572, 589 to 592)</a:t>
+              <a:t>The keyboard, and the free gear keys (Lines 535 to 572, 615 to 618)</a:t>
             </a:r>
           </a:p>
         </p:txBody>
@@ -8178,7 +8178,7 @@
           <a:p>
             <a:r>
               <a:rPr sz="2600"/>
-              <a:t>Sample once, hold, then send state back (Lines 710 to 722, 745 to 755)</a:t>
+              <a:t>Sample once, hold, then send state back (Lines 710 to 722, 771 to 781)</a:t>
             </a:r>
           </a:p>
         </p:txBody>

</xml_diff>